<commit_message>
Improve y-axis-log visual presentation
Also remove x-axis grid lines and tick marks, since exon model is not linearly scaled.
</commit_message>
<xml_diff>
--- a/FCER1G_Gnomad_variants.paste_up.pptx
+++ b/FCER1G_Gnomad_variants.paste_up.pptx
@@ -110,6 +110,11 @@
       </a:defRPr>
     </a:lvl9pPr>
   </p:defaultTextStyle>
+  <p:extLst>
+    <p:ext uri="{EFAFB233-063F-42B5-8137-9DF3F51BA10A}">
+      <p15:sldGuideLst xmlns:p15="http://schemas.microsoft.com/office/powerpoint/2012/main"/>
+    </p:ext>
+  </p:extLst>
 </p:presentation>
 </file>
 
@@ -8286,10 +8291,10 @@
       </p:grpSpPr>
       <p:pic>
         <p:nvPicPr>
-          <p:cNvPr id="88" name="Picture 87">
+          <p:cNvPr id="5" name="Picture 4">
             <a:extLst>
               <a:ext uri="{FF2B5EF4-FFF2-40B4-BE49-F238E27FC236}">
-                <a16:creationId xmlns:a16="http://schemas.microsoft.com/office/drawing/2014/main" id="{191B0814-DDC4-794B-691A-87F925365693}"/>
+                <a16:creationId xmlns:a16="http://schemas.microsoft.com/office/drawing/2014/main" id="{17C795C1-249C-1420-105A-F61344BC43B7}"/>
               </a:ext>
             </a:extLst>
           </p:cNvPr>
@@ -8306,8 +8311,8 @@
         </p:blipFill>
         <p:spPr>
           <a:xfrm>
-            <a:off x="1638789" y="1003258"/>
-            <a:ext cx="8336948" cy="3886200"/>
+            <a:off x="1637912" y="800007"/>
+            <a:ext cx="8282553" cy="4141277"/>
           </a:xfrm>
           <a:prstGeom prst="rect">
             <a:avLst/>

</xml_diff>

<commit_message>
Bold the dominant/common allele protein in HGVS labels
2 of our 5 SNPs have AF > 0.5, meaning that the ref genome has the minor allele.
Since we plot the variant at 1-AF, in those cases, we added bold/underline of one AA in the HGVS labels to indicate which one is the dominant allele (since order indicates which one is REF vs ALT).

Also added darker major y lines in the grid background.
</commit_message>
<xml_diff>
--- a/FCER1G_Gnomad_variants.paste_up.pptx
+++ b/FCER1G_Gnomad_variants.paste_up.pptx
@@ -200,7 +200,7 @@
           <a:p>
             <a:fld id="{EE09F260-7163-3748-9F15-2A5DC282F23A}" type="datetimeFigureOut">
               <a:rPr lang="en-US" smtClean="0"/>
-              <a:t>12/8/25</a:t>
+              <a:t>7/20/26</a:t>
             </a:fld>
             <a:endParaRPr lang="en-US"/>
           </a:p>
@@ -1088,7 +1088,7 @@
           <a:p>
             <a:fld id="{F7A2E23E-EA94-0246-9AF1-047D01A2B122}" type="datetimeFigureOut">
               <a:rPr lang="en-US" smtClean="0"/>
-              <a:t>12/8/25</a:t>
+              <a:t>7/20/26</a:t>
             </a:fld>
             <a:endParaRPr lang="en-US"/>
           </a:p>
@@ -1286,7 +1286,7 @@
           <a:p>
             <a:fld id="{F7A2E23E-EA94-0246-9AF1-047D01A2B122}" type="datetimeFigureOut">
               <a:rPr lang="en-US" smtClean="0"/>
-              <a:t>12/8/25</a:t>
+              <a:t>7/20/26</a:t>
             </a:fld>
             <a:endParaRPr lang="en-US"/>
           </a:p>
@@ -1494,7 +1494,7 @@
           <a:p>
             <a:fld id="{F7A2E23E-EA94-0246-9AF1-047D01A2B122}" type="datetimeFigureOut">
               <a:rPr lang="en-US" smtClean="0"/>
-              <a:t>12/8/25</a:t>
+              <a:t>7/20/26</a:t>
             </a:fld>
             <a:endParaRPr lang="en-US"/>
           </a:p>
@@ -1692,7 +1692,7 @@
           <a:p>
             <a:fld id="{F7A2E23E-EA94-0246-9AF1-047D01A2B122}" type="datetimeFigureOut">
               <a:rPr lang="en-US" smtClean="0"/>
-              <a:t>12/8/25</a:t>
+              <a:t>7/20/26</a:t>
             </a:fld>
             <a:endParaRPr lang="en-US"/>
           </a:p>
@@ -1967,7 +1967,7 @@
           <a:p>
             <a:fld id="{F7A2E23E-EA94-0246-9AF1-047D01A2B122}" type="datetimeFigureOut">
               <a:rPr lang="en-US" smtClean="0"/>
-              <a:t>12/8/25</a:t>
+              <a:t>7/20/26</a:t>
             </a:fld>
             <a:endParaRPr lang="en-US"/>
           </a:p>
@@ -2232,7 +2232,7 @@
           <a:p>
             <a:fld id="{F7A2E23E-EA94-0246-9AF1-047D01A2B122}" type="datetimeFigureOut">
               <a:rPr lang="en-US" smtClean="0"/>
-              <a:t>12/8/25</a:t>
+              <a:t>7/20/26</a:t>
             </a:fld>
             <a:endParaRPr lang="en-US"/>
           </a:p>
@@ -2644,7 +2644,7 @@
           <a:p>
             <a:fld id="{F7A2E23E-EA94-0246-9AF1-047D01A2B122}" type="datetimeFigureOut">
               <a:rPr lang="en-US" smtClean="0"/>
-              <a:t>12/8/25</a:t>
+              <a:t>7/20/26</a:t>
             </a:fld>
             <a:endParaRPr lang="en-US"/>
           </a:p>
@@ -2785,7 +2785,7 @@
           <a:p>
             <a:fld id="{F7A2E23E-EA94-0246-9AF1-047D01A2B122}" type="datetimeFigureOut">
               <a:rPr lang="en-US" smtClean="0"/>
-              <a:t>12/8/25</a:t>
+              <a:t>7/20/26</a:t>
             </a:fld>
             <a:endParaRPr lang="en-US"/>
           </a:p>
@@ -2898,7 +2898,7 @@
           <a:p>
             <a:fld id="{F7A2E23E-EA94-0246-9AF1-047D01A2B122}" type="datetimeFigureOut">
               <a:rPr lang="en-US" smtClean="0"/>
-              <a:t>12/8/25</a:t>
+              <a:t>7/20/26</a:t>
             </a:fld>
             <a:endParaRPr lang="en-US"/>
           </a:p>
@@ -3209,7 +3209,7 @@
           <a:p>
             <a:fld id="{F7A2E23E-EA94-0246-9AF1-047D01A2B122}" type="datetimeFigureOut">
               <a:rPr lang="en-US" smtClean="0"/>
-              <a:t>12/8/25</a:t>
+              <a:t>7/20/26</a:t>
             </a:fld>
             <a:endParaRPr lang="en-US"/>
           </a:p>
@@ -3497,7 +3497,7 @@
           <a:p>
             <a:fld id="{F7A2E23E-EA94-0246-9AF1-047D01A2B122}" type="datetimeFigureOut">
               <a:rPr lang="en-US" smtClean="0"/>
-              <a:t>12/8/25</a:t>
+              <a:t>7/20/26</a:t>
             </a:fld>
             <a:endParaRPr lang="en-US"/>
           </a:p>
@@ -3738,7 +3738,7 @@
           <a:p>
             <a:fld id="{F7A2E23E-EA94-0246-9AF1-047D01A2B122}" type="datetimeFigureOut">
               <a:rPr lang="en-US" smtClean="0"/>
-              <a:t>12/8/25</a:t>
+              <a:t>7/20/26</a:t>
             </a:fld>
             <a:endParaRPr lang="en-US"/>
           </a:p>
@@ -8291,10 +8291,10 @@
       </p:grpSpPr>
       <p:pic>
         <p:nvPicPr>
-          <p:cNvPr id="5" name="Picture 4">
+          <p:cNvPr id="4" name="Picture 3">
             <a:extLst>
               <a:ext uri="{FF2B5EF4-FFF2-40B4-BE49-F238E27FC236}">
-                <a16:creationId xmlns:a16="http://schemas.microsoft.com/office/drawing/2014/main" id="{17C795C1-249C-1420-105A-F61344BC43B7}"/>
+                <a16:creationId xmlns:a16="http://schemas.microsoft.com/office/drawing/2014/main" id="{548D4C14-B91C-5379-EA1D-4CB0EE2AFF54}"/>
               </a:ext>
             </a:extLst>
           </p:cNvPr>
@@ -8311,8 +8311,8 @@
         </p:blipFill>
         <p:spPr>
           <a:xfrm>
-            <a:off x="1637912" y="800007"/>
-            <a:ext cx="8282553" cy="4141277"/>
+            <a:off x="1629072" y="770705"/>
+            <a:ext cx="8284464" cy="4142232"/>
           </a:xfrm>
           <a:prstGeom prst="rect">
             <a:avLst/>

</xml_diff>